<commit_message>
fix(presentacion): corregir solapamiento de textos en diagrama de bandas y diapositiva 2
</commit_message>
<xml_diff>
--- a/problemas/5_Materials_Uriel/presentacion_materiales_uriel.pptx
+++ b/problemas/5_Materials_Uriel/presentacion_materiales_uriel.pptx
@@ -4470,8 +4470,8 @@
         </p:nvSpPr>
         <p:spPr>
           <a:xfrm>
-            <a:off x="731520" y="1417320"/>
-            <a:ext cx="10728655" cy="1234440"/>
+            <a:off x="731520" y="1325880"/>
+            <a:ext cx="10728655" cy="1143000"/>
           </a:xfrm>
           <a:prstGeom prst="roundRect">
             <a:avLst/>
@@ -4519,8 +4519,8 @@
         </p:nvSpPr>
         <p:spPr>
           <a:xfrm>
-            <a:off x="914400" y="1463040"/>
-            <a:ext cx="10332720" cy="320040"/>
+            <a:off x="914400" y="1371600"/>
+            <a:ext cx="10332720" cy="274320"/>
           </a:xfrm>
           <a:prstGeom prst="rect">
             <a:avLst/>
@@ -4534,7 +4534,7 @@
           <a:lstStyle/>
           <a:p>
             <a:pPr>
-              <a:defRPr sz="1200" b="1">
+              <a:defRPr sz="1150" b="1">
                 <a:solidFill>
                   <a:srgbClr val="000000"/>
                 </a:solidFill>
@@ -4566,8 +4566,8 @@
         </p:blipFill>
         <p:spPr>
           <a:xfrm>
-            <a:off x="1645920" y="1783080"/>
-            <a:ext cx="8869680" cy="1424232"/>
+            <a:off x="2194560" y="1664208"/>
+            <a:ext cx="7772400" cy="1248039"/>
           </a:xfrm>
           <a:prstGeom prst="rect">
             <a:avLst/>
@@ -4590,8 +4590,8 @@
         </p:blipFill>
         <p:spPr>
           <a:xfrm>
-            <a:off x="731520" y="2788920"/>
-            <a:ext cx="10728655" cy="4015864"/>
+            <a:off x="731520" y="2606040"/>
+            <a:ext cx="10728655" cy="3800847"/>
           </a:xfrm>
           <a:prstGeom prst="rect">
             <a:avLst/>

</xml_diff>